<commit_message>
Fix management deck long-title layout
</commit_message>
<xml_diff>
--- a/deliverables/management_briefing_deck.pptx
+++ b/deliverables/management_briefing_deck.pptx
@@ -3763,7 +3763,7 @@
         <p:spPr>
           <a:xfrm>
             <a:off x="621792" y="1298448"/>
-            <a:ext cx="10652760" cy="402336"/>
+            <a:ext cx="10652760" cy="274320"/>
           </a:xfrm>
           <a:prstGeom prst="rect">
             <a:avLst/>
@@ -5102,7 +5102,7 @@
         <p:spPr>
           <a:xfrm>
             <a:off x="621792" y="1298448"/>
-            <a:ext cx="10652760" cy="402336"/>
+            <a:ext cx="10652760" cy="274320"/>
           </a:xfrm>
           <a:prstGeom prst="rect">
             <a:avLst/>
@@ -7094,7 +7094,7 @@
         <p:spPr>
           <a:xfrm>
             <a:off x="621792" y="1298448"/>
-            <a:ext cx="10652760" cy="402336"/>
+            <a:ext cx="10652760" cy="274320"/>
           </a:xfrm>
           <a:prstGeom prst="rect">
             <a:avLst/>
@@ -9275,8 +9275,8 @@
         </p:nvSpPr>
         <p:spPr>
           <a:xfrm>
-            <a:off x="621792" y="749808"/>
-            <a:ext cx="10744200" cy="566928"/>
+            <a:off x="621792" y="713232"/>
+            <a:ext cx="10744200" cy="749808"/>
           </a:xfrm>
           <a:prstGeom prst="rect">
             <a:avLst/>
@@ -9295,7 +9295,7 @@
               </a:spcAft>
             </a:pPr>
             <a:r>
-              <a:rPr sz="2800" b="1">
+              <a:rPr sz="2400" b="1">
                 <a:solidFill>
                   <a:srgbClr val="10263C"/>
                 </a:solidFill>
@@ -9314,8 +9314,8 @@
         </p:nvSpPr>
         <p:spPr>
           <a:xfrm>
-            <a:off x="621792" y="1298448"/>
-            <a:ext cx="10652760" cy="402336"/>
+            <a:off x="621792" y="1481328"/>
+            <a:ext cx="10652760" cy="274320"/>
           </a:xfrm>
           <a:prstGeom prst="rect">
             <a:avLst/>
@@ -10585,8 +10585,8 @@
         </p:nvSpPr>
         <p:spPr>
           <a:xfrm>
-            <a:off x="621792" y="749808"/>
-            <a:ext cx="10744200" cy="566928"/>
+            <a:off x="621792" y="713232"/>
+            <a:ext cx="10744200" cy="749808"/>
           </a:xfrm>
           <a:prstGeom prst="rect">
             <a:avLst/>
@@ -10605,7 +10605,7 @@
               </a:spcAft>
             </a:pPr>
             <a:r>
-              <a:rPr sz="2800" b="1">
+              <a:rPr sz="2400" b="1">
                 <a:solidFill>
                   <a:srgbClr val="10263C"/>
                 </a:solidFill>
@@ -10624,8 +10624,8 @@
         </p:nvSpPr>
         <p:spPr>
           <a:xfrm>
-            <a:off x="621792" y="1298448"/>
-            <a:ext cx="10652760" cy="402336"/>
+            <a:off x="621792" y="1481328"/>
+            <a:ext cx="10652760" cy="274320"/>
           </a:xfrm>
           <a:prstGeom prst="rect">
             <a:avLst/>

</xml_diff>

<commit_message>
Surface R01 baseline in executive artifacts
</commit_message>
<xml_diff>
--- a/deliverables/management_briefing_deck.pptx
+++ b/deliverables/management_briefing_deck.pptx
@@ -4637,7 +4637,7 @@
                 </a:solidFill>
                 <a:latin typeface="Aptos"/>
               </a:rPr>
-              <a:t>Undergraduate U.S. nonresident enrollment increased +31,592 in 2024.</a:t>
+              <a:t>Undergraduate enrollment increased +31,592 across 45 of 51 states/DC; public institutions contributed +28,580.</a:t>
             </a:r>
           </a:p>
         </p:txBody>
@@ -4832,7 +4832,7 @@
                 </a:solidFill>
                 <a:latin typeface="Aptos"/>
               </a:rPr>
-              <a:t>Most movement was within existing institutions</a:t>
+              <a:t>Existing institutions drove the gain</a:t>
             </a:r>
           </a:p>
         </p:txBody>
@@ -11226,7 +11226,7 @@
                 </a:solidFill>
                 <a:latin typeface="Aptos"/>
               </a:rPr>
-              <a:t>When a new IPEDS release arrives, rerun schema, QA, benchmark, SQL, and publication checks before refreshing this deck.</a:t>
+              <a:t>R01 is pre-specified: call the undergraduate shift broadly persistent only if the next complete release is positive nationally and in at least 26 of 51 states/DC.</a:t>
             </a:r>
           </a:p>
         </p:txBody>

</xml_diff>

<commit_message>
Align management deck with distilled data story
</commit_message>
<xml_diff>
--- a/deliverables/management_briefing_deck.pptx
+++ b/deliverables/management_briefing_deck.pptx
@@ -3620,7 +3620,7 @@
                 </a:solidFill>
                 <a:latin typeface="Aptos"/>
               </a:rPr>
-              <a:t>RECOVERED VS 2019</a:t>
+              <a:t>UNDERGRADUATE CHANGE</a:t>
             </a:r>
           </a:p>
         </p:txBody>
@@ -3659,7 +3659,7 @@
                 </a:solidFill>
                 <a:latin typeface="Aptos"/>
               </a:rPr>
-              <a:t>33 of 51</a:t>
+              <a:t>+31,592</a:t>
             </a:r>
           </a:p>
         </p:txBody>
@@ -3698,7 +3698,7 @@
                 </a:solidFill>
                 <a:latin typeface="Aptos"/>
               </a:rPr>
-              <a:t>18 remain below 2019</a:t>
+              <a:t>45 of 51 states/DC increased</a:t>
             </a:r>
           </a:p>
         </p:txBody>
@@ -3874,7 +3874,7 @@
         <p:spPr>
           <a:xfrm>
             <a:off x="621792" y="3383280"/>
-            <a:ext cx="10972800" cy="2514600"/>
+            <a:ext cx="6903720" cy="2514600"/>
           </a:xfrm>
           <a:prstGeom prst="roundRect">
             <a:avLst/>
@@ -3919,7 +3919,7 @@
         <p:spPr>
           <a:xfrm>
             <a:off x="896112" y="3639312"/>
-            <a:ext cx="3840480" cy="292608"/>
+            <a:ext cx="4206240" cy="292608"/>
           </a:xfrm>
           <a:prstGeom prst="rect">
             <a:avLst/>
@@ -3944,7 +3944,7 @@
                 </a:solidFill>
                 <a:latin typeface="Aptos"/>
               </a:rPr>
-              <a:t>What changed in the latest release</a:t>
+              <a:t>What changed from 2023 to 2024?</a:t>
             </a:r>
           </a:p>
         </p:txBody>
@@ -3957,8 +3957,8 @@
         </p:nvSpPr>
         <p:spPr>
           <a:xfrm>
-            <a:off x="896112" y="4114800"/>
-            <a:ext cx="310896" cy="219456"/>
+            <a:off x="896112" y="3941063"/>
+            <a:ext cx="5029200" cy="201168"/>
           </a:xfrm>
           <a:prstGeom prst="rect">
             <a:avLst/>
@@ -3977,13 +3977,13 @@
               </a:spcAft>
             </a:pPr>
             <a:r>
-              <a:rPr sz="900" b="1">
-                <a:solidFill>
-                  <a:srgbClr val="07564F"/>
-                </a:solidFill>
-                <a:latin typeface="Aptos"/>
-              </a:rPr>
-              <a:t>01</a:t>
+              <a:rPr sz="900" b="0">
+                <a:solidFill>
+                  <a:srgbClr val="5D6D7E"/>
+                </a:solidFill>
+                <a:latin typeface="Aptos"/>
+              </a:rPr>
+              <a:t>Change in U.S. nonresident enrollment by student level</a:t>
             </a:r>
           </a:p>
         </p:txBody>
@@ -3996,8 +3996,8 @@
         </p:nvSpPr>
         <p:spPr>
           <a:xfrm>
-            <a:off x="1280160" y="4096512"/>
-            <a:ext cx="2862072" cy="246888"/>
+            <a:off x="896112" y="4334256"/>
+            <a:ext cx="1225296" cy="219456"/>
           </a:xfrm>
           <a:prstGeom prst="rect">
             <a:avLst/>
@@ -4016,307 +4016,79 @@
               </a:spcAft>
             </a:pPr>
             <a:r>
-              <a:rPr sz="1200" b="1">
+              <a:rPr sz="919" b="1">
                 <a:solidFill>
                   <a:srgbClr val="10263C"/>
                 </a:solidFill>
                 <a:latin typeface="Aptos"/>
               </a:rPr>
-              <a:t>Undergraduate growth led</a:t>
-            </a:r>
-          </a:p>
-        </p:txBody>
-      </p:sp>
-      <p:sp>
-        <p:nvSpPr>
-          <p:cNvPr id="25" name="TextBox 24"/>
-          <p:cNvSpPr txBox="1"/>
-          <p:nvPr/>
-        </p:nvSpPr>
-        <p:spPr>
-          <a:xfrm>
-            <a:off x="1280160" y="4379976"/>
-            <a:ext cx="2862072" cy="457200"/>
-          </a:xfrm>
-          <a:prstGeom prst="rect">
-            <a:avLst/>
-          </a:prstGeom>
-          <a:noFill/>
-        </p:spPr>
-        <p:txBody>
-          <a:bodyPr wrap="square" lIns="0" rIns="0" tIns="0" bIns="0" anchor="t">
-            <a:spAutoFit/>
-          </a:bodyPr>
-          <a:lstStyle/>
-          <a:p>
-            <a:pPr algn="l">
-              <a:spcAft>
-                <a:spcPts val="0"/>
-              </a:spcAft>
-            </a:pPr>
-            <a:r>
-              <a:rPr sz="950" b="0">
-                <a:solidFill>
-                  <a:srgbClr val="5D6D7E"/>
-                </a:solidFill>
-                <a:latin typeface="Aptos"/>
-              </a:rPr>
-              <a:t>Undergraduate enrollment increased +31,592 across 45 of 51 states/DC; public institutions contributed +28,580.</a:t>
-            </a:r>
-          </a:p>
-        </p:txBody>
-      </p:sp>
-      <p:sp>
-        <p:nvSpPr>
-          <p:cNvPr id="26" name="TextBox 25"/>
-          <p:cNvSpPr txBox="1"/>
-          <p:nvPr/>
-        </p:nvSpPr>
-        <p:spPr>
-          <a:xfrm>
-            <a:off x="4160520" y="4114800"/>
-            <a:ext cx="310896" cy="219456"/>
-          </a:xfrm>
-          <a:prstGeom prst="rect">
-            <a:avLst/>
-          </a:prstGeom>
-          <a:noFill/>
-        </p:spPr>
-        <p:txBody>
-          <a:bodyPr wrap="square" lIns="0" rIns="0" tIns="0" bIns="0" anchor="t">
-            <a:spAutoFit/>
-          </a:bodyPr>
-          <a:lstStyle/>
-          <a:p>
-            <a:pPr algn="l">
-              <a:spcAft>
-                <a:spcPts val="0"/>
-              </a:spcAft>
-            </a:pPr>
-            <a:r>
-              <a:rPr sz="900" b="1">
-                <a:solidFill>
-                  <a:srgbClr val="07564F"/>
-                </a:solidFill>
-                <a:latin typeface="Aptos"/>
-              </a:rPr>
-              <a:t>02</a:t>
-            </a:r>
-          </a:p>
-        </p:txBody>
-      </p:sp>
-      <p:sp>
-        <p:nvSpPr>
-          <p:cNvPr id="27" name="TextBox 26"/>
-          <p:cNvSpPr txBox="1"/>
-          <p:nvPr/>
-        </p:nvSpPr>
-        <p:spPr>
-          <a:xfrm>
-            <a:off x="4544568" y="4096512"/>
-            <a:ext cx="2953512" cy="246888"/>
-          </a:xfrm>
-          <a:prstGeom prst="rect">
-            <a:avLst/>
-          </a:prstGeom>
-          <a:noFill/>
-        </p:spPr>
-        <p:txBody>
-          <a:bodyPr wrap="square" lIns="0" rIns="0" tIns="0" bIns="0" anchor="t">
-            <a:spAutoFit/>
-          </a:bodyPr>
-          <a:lstStyle/>
-          <a:p>
-            <a:pPr algn="l">
-              <a:spcAft>
-                <a:spcPts val="0"/>
-              </a:spcAft>
-            </a:pPr>
-            <a:r>
-              <a:rPr sz="1200" b="1">
-                <a:solidFill>
-                  <a:srgbClr val="10263C"/>
-                </a:solidFill>
-                <a:latin typeface="Aptos"/>
-              </a:rPr>
-              <a:t>Graduate enrollment edged down</a:t>
-            </a:r>
-          </a:p>
-        </p:txBody>
-      </p:sp>
-      <p:sp>
-        <p:nvSpPr>
-          <p:cNvPr id="28" name="TextBox 27"/>
-          <p:cNvSpPr txBox="1"/>
-          <p:nvPr/>
-        </p:nvSpPr>
-        <p:spPr>
-          <a:xfrm>
-            <a:off x="4544568" y="4379976"/>
-            <a:ext cx="2953512" cy="457200"/>
-          </a:xfrm>
-          <a:prstGeom prst="rect">
-            <a:avLst/>
-          </a:prstGeom>
-          <a:noFill/>
-        </p:spPr>
-        <p:txBody>
-          <a:bodyPr wrap="square" lIns="0" rIns="0" tIns="0" bIns="0" anchor="t">
-            <a:spAutoFit/>
-          </a:bodyPr>
-          <a:lstStyle/>
-          <a:p>
-            <a:pPr algn="l">
-              <a:spcAft>
-                <a:spcPts val="0"/>
-              </a:spcAft>
-            </a:pPr>
-            <a:r>
-              <a:rPr sz="950" b="0">
-                <a:solidFill>
-                  <a:srgbClr val="5D6D7E"/>
-                </a:solidFill>
-                <a:latin typeface="Aptos"/>
-              </a:rPr>
-              <a:t>Graduate enrollment changed -2,053, so the net gain was not graduate-driven in the latest year.</a:t>
-            </a:r>
-          </a:p>
-        </p:txBody>
-      </p:sp>
-      <p:sp>
-        <p:nvSpPr>
-          <p:cNvPr id="29" name="TextBox 28"/>
-          <p:cNvSpPr txBox="1"/>
-          <p:nvPr/>
-        </p:nvSpPr>
-        <p:spPr>
-          <a:xfrm>
-            <a:off x="7635240" y="4114800"/>
-            <a:ext cx="310896" cy="219456"/>
-          </a:xfrm>
-          <a:prstGeom prst="rect">
-            <a:avLst/>
-          </a:prstGeom>
-          <a:noFill/>
-        </p:spPr>
-        <p:txBody>
-          <a:bodyPr wrap="square" lIns="0" rIns="0" tIns="0" bIns="0" anchor="t">
-            <a:spAutoFit/>
-          </a:bodyPr>
-          <a:lstStyle/>
-          <a:p>
-            <a:pPr algn="l">
-              <a:spcAft>
-                <a:spcPts val="0"/>
-              </a:spcAft>
-            </a:pPr>
-            <a:r>
-              <a:rPr sz="900" b="1">
-                <a:solidFill>
-                  <a:srgbClr val="07564F"/>
-                </a:solidFill>
-                <a:latin typeface="Aptos"/>
-              </a:rPr>
-              <a:t>03</a:t>
-            </a:r>
-          </a:p>
-        </p:txBody>
-      </p:sp>
-      <p:sp>
-        <p:nvSpPr>
-          <p:cNvPr id="30" name="TextBox 29"/>
-          <p:cNvSpPr txBox="1"/>
-          <p:nvPr/>
-        </p:nvSpPr>
-        <p:spPr>
-          <a:xfrm>
-            <a:off x="8019288" y="4096512"/>
-            <a:ext cx="3136392" cy="246888"/>
-          </a:xfrm>
-          <a:prstGeom prst="rect">
-            <a:avLst/>
-          </a:prstGeom>
-          <a:noFill/>
-        </p:spPr>
-        <p:txBody>
-          <a:bodyPr wrap="square" lIns="0" rIns="0" tIns="0" bIns="0" anchor="t">
-            <a:spAutoFit/>
-          </a:bodyPr>
-          <a:lstStyle/>
-          <a:p>
-            <a:pPr algn="l">
-              <a:spcAft>
-                <a:spcPts val="0"/>
-              </a:spcAft>
-            </a:pPr>
-            <a:r>
-              <a:rPr sz="1200" b="1">
-                <a:solidFill>
-                  <a:srgbClr val="10263C"/>
-                </a:solidFill>
-                <a:latin typeface="Aptos"/>
-              </a:rPr>
-              <a:t>Existing institutions drove the gain</a:t>
-            </a:r>
-          </a:p>
-        </p:txBody>
-      </p:sp>
-      <p:sp>
-        <p:nvSpPr>
-          <p:cNvPr id="31" name="TextBox 30"/>
-          <p:cNvSpPr txBox="1"/>
-          <p:nvPr/>
-        </p:nvSpPr>
-        <p:spPr>
-          <a:xfrm>
-            <a:off x="8019288" y="4379976"/>
-            <a:ext cx="3136392" cy="457200"/>
-          </a:xfrm>
-          <a:prstGeom prst="rect">
-            <a:avLst/>
-          </a:prstGeom>
-          <a:noFill/>
-        </p:spPr>
-        <p:txBody>
-          <a:bodyPr wrap="square" lIns="0" rIns="0" tIns="0" bIns="0" anchor="t">
-            <a:spAutoFit/>
-          </a:bodyPr>
-          <a:lstStyle/>
-          <a:p>
-            <a:pPr algn="l">
-              <a:spcAft>
-                <a:spcPts val="0"/>
-              </a:spcAft>
-            </a:pPr>
-            <a:r>
-              <a:rPr sz="950" b="0">
-                <a:solidFill>
-                  <a:srgbClr val="5D6D7E"/>
-                </a:solidFill>
-                <a:latin typeface="Aptos"/>
-              </a:rPr>
-              <a:t>Continuing institutions accounted for +29,968; entry/exit netted -429.</a:t>
-            </a:r>
+              <a:t>Undergraduate</a:t>
+            </a:r>
+          </a:p>
+        </p:txBody>
+      </p:sp>
+      <p:sp>
+        <p:nvSpPr>
+          <p:cNvPr id="25" name="Rectangle 24"/>
+          <p:cNvSpPr/>
+          <p:nvPr/>
+        </p:nvSpPr>
+        <p:spPr>
+          <a:xfrm>
+            <a:off x="2286000" y="4370831"/>
+            <a:ext cx="3758184" cy="146304"/>
+          </a:xfrm>
+          <a:prstGeom prst="rect">
+            <a:avLst/>
+          </a:prstGeom>
+          <a:solidFill>
+            <a:srgbClr val="F0F4F7"/>
+          </a:solidFill>
+          <a:ln w="10160">
+            <a:solidFill>
+              <a:srgbClr val="F0F4F7"/>
+            </a:solidFill>
+          </a:ln>
+        </p:spPr>
+        <p:style>
+          <a:lnRef idx="1">
+            <a:schemeClr val="accent1"/>
+          </a:lnRef>
+          <a:fillRef idx="3">
+            <a:schemeClr val="accent1"/>
+          </a:fillRef>
+          <a:effectRef idx="2">
+            <a:schemeClr val="accent1"/>
+          </a:effectRef>
+          <a:fontRef idx="minor">
+            <a:schemeClr val="lt1"/>
+          </a:fontRef>
+        </p:style>
+        <p:txBody>
+          <a:bodyPr rtlCol="0" anchor="ctr"/>
+          <a:lstStyle/>
+          <a:p>
+            <a:pPr algn="ctr"/>
           </a:p>
         </p:txBody>
       </p:sp>
       <p:cxnSp>
         <p:nvCxnSpPr>
-          <p:cNvPr id="32" name="Connector 31"/>
+          <p:cNvPr id="26" name="Connector 25"/>
           <p:cNvCxnSpPr/>
           <p:nvPr/>
         </p:nvCxnSpPr>
         <p:spPr>
           <a:xfrm>
-            <a:off x="594360" y="6510528"/>
-            <a:ext cx="10972800" cy="0"/>
+            <a:off x="4165092" y="4334256"/>
+            <a:ext cx="0" cy="219456"/>
           </a:xfrm>
           <a:prstGeom prst="line">
             <a:avLst/>
           </a:prstGeom>
           <a:ln w="10160">
             <a:solidFill>
-              <a:srgbClr val="D9E1E8"/>
+              <a:srgbClr val="9FB0C0"/>
             </a:solidFill>
           </a:ln>
         </p:spPr>
@@ -4337,7 +4109,807 @@
       </p:cxnSp>
       <p:sp>
         <p:nvSpPr>
+          <p:cNvPr id="27" name="Rectangle 26"/>
+          <p:cNvSpPr/>
+          <p:nvPr/>
+        </p:nvSpPr>
+        <p:spPr>
+          <a:xfrm>
+            <a:off x="4165092" y="4370831"/>
+            <a:ext cx="1842516" cy="146304"/>
+          </a:xfrm>
+          <a:prstGeom prst="rect">
+            <a:avLst/>
+          </a:prstGeom>
+          <a:solidFill>
+            <a:srgbClr val="0B776E"/>
+          </a:solidFill>
+          <a:ln w="10160">
+            <a:solidFill>
+              <a:srgbClr val="0B776E"/>
+            </a:solidFill>
+          </a:ln>
+        </p:spPr>
+        <p:style>
+          <a:lnRef idx="1">
+            <a:schemeClr val="accent1"/>
+          </a:lnRef>
+          <a:fillRef idx="3">
+            <a:schemeClr val="accent1"/>
+          </a:fillRef>
+          <a:effectRef idx="2">
+            <a:schemeClr val="accent1"/>
+          </a:effectRef>
+          <a:fontRef idx="minor">
+            <a:schemeClr val="lt1"/>
+          </a:fontRef>
+        </p:style>
+        <p:txBody>
+          <a:bodyPr rtlCol="0" anchor="ctr"/>
+          <a:lstStyle/>
+          <a:p>
+            <a:pPr algn="ctr"/>
+          </a:p>
+        </p:txBody>
+      </p:sp>
+      <p:sp>
+        <p:nvSpPr>
+          <p:cNvPr id="28" name="TextBox 27"/>
+          <p:cNvSpPr txBox="1"/>
+          <p:nvPr/>
+        </p:nvSpPr>
+        <p:spPr>
+          <a:xfrm>
+            <a:off x="6227064" y="4325112"/>
+            <a:ext cx="932688" cy="219456"/>
+          </a:xfrm>
+          <a:prstGeom prst="rect">
+            <a:avLst/>
+          </a:prstGeom>
+          <a:noFill/>
+        </p:spPr>
+        <p:txBody>
+          <a:bodyPr wrap="square" lIns="0" rIns="0" tIns="0" bIns="0" anchor="t">
+            <a:spAutoFit/>
+          </a:bodyPr>
+          <a:lstStyle/>
+          <a:p>
+            <a:pPr algn="r">
+              <a:spcAft>
+                <a:spcPts val="0"/>
+              </a:spcAft>
+            </a:pPr>
+            <a:r>
+              <a:rPr sz="900" b="1">
+                <a:solidFill>
+                  <a:srgbClr val="5D6D7E"/>
+                </a:solidFill>
+                <a:latin typeface="Aptos"/>
+              </a:rPr>
+              <a:t>+31,592</a:t>
+            </a:r>
+          </a:p>
+        </p:txBody>
+      </p:sp>
+      <p:sp>
+        <p:nvSpPr>
+          <p:cNvPr id="29" name="TextBox 28"/>
+          <p:cNvSpPr txBox="1"/>
+          <p:nvPr/>
+        </p:nvSpPr>
+        <p:spPr>
+          <a:xfrm>
+            <a:off x="896112" y="4800600"/>
+            <a:ext cx="1225296" cy="219456"/>
+          </a:xfrm>
+          <a:prstGeom prst="rect">
+            <a:avLst/>
+          </a:prstGeom>
+          <a:noFill/>
+        </p:spPr>
+        <p:txBody>
+          <a:bodyPr wrap="square" lIns="0" rIns="0" tIns="0" bIns="0" anchor="t">
+            <a:spAutoFit/>
+          </a:bodyPr>
+          <a:lstStyle/>
+          <a:p>
+            <a:pPr algn="l">
+              <a:spcAft>
+                <a:spcPts val="0"/>
+              </a:spcAft>
+            </a:pPr>
+            <a:r>
+              <a:rPr sz="919" b="1">
+                <a:solidFill>
+                  <a:srgbClr val="10263C"/>
+                </a:solidFill>
+                <a:latin typeface="Aptos"/>
+              </a:rPr>
+              <a:t>Graduate</a:t>
+            </a:r>
+          </a:p>
+        </p:txBody>
+      </p:sp>
+      <p:sp>
+        <p:nvSpPr>
+          <p:cNvPr id="30" name="Rectangle 29"/>
+          <p:cNvSpPr/>
+          <p:nvPr/>
+        </p:nvSpPr>
+        <p:spPr>
+          <a:xfrm>
+            <a:off x="2286000" y="4837175"/>
+            <a:ext cx="3758184" cy="146304"/>
+          </a:xfrm>
+          <a:prstGeom prst="rect">
+            <a:avLst/>
+          </a:prstGeom>
+          <a:solidFill>
+            <a:srgbClr val="F0F4F7"/>
+          </a:solidFill>
+          <a:ln w="10160">
+            <a:solidFill>
+              <a:srgbClr val="F0F4F7"/>
+            </a:solidFill>
+          </a:ln>
+        </p:spPr>
+        <p:style>
+          <a:lnRef idx="1">
+            <a:schemeClr val="accent1"/>
+          </a:lnRef>
+          <a:fillRef idx="3">
+            <a:schemeClr val="accent1"/>
+          </a:fillRef>
+          <a:effectRef idx="2">
+            <a:schemeClr val="accent1"/>
+          </a:effectRef>
+          <a:fontRef idx="minor">
+            <a:schemeClr val="lt1"/>
+          </a:fontRef>
+        </p:style>
+        <p:txBody>
+          <a:bodyPr rtlCol="0" anchor="ctr"/>
+          <a:lstStyle/>
+          <a:p>
+            <a:pPr algn="ctr"/>
+          </a:p>
+        </p:txBody>
+      </p:sp>
+      <p:cxnSp>
+        <p:nvCxnSpPr>
+          <p:cNvPr id="31" name="Connector 30"/>
+          <p:cNvCxnSpPr/>
+          <p:nvPr/>
+        </p:nvCxnSpPr>
+        <p:spPr>
+          <a:xfrm>
+            <a:off x="4165092" y="4800600"/>
+            <a:ext cx="0" cy="219455"/>
+          </a:xfrm>
+          <a:prstGeom prst="line">
+            <a:avLst/>
+          </a:prstGeom>
+          <a:ln w="10160">
+            <a:solidFill>
+              <a:srgbClr val="9FB0C0"/>
+            </a:solidFill>
+          </a:ln>
+        </p:spPr>
+        <p:style>
+          <a:lnRef idx="2">
+            <a:schemeClr val="accent1"/>
+          </a:lnRef>
+          <a:fillRef idx="0">
+            <a:schemeClr val="accent1"/>
+          </a:fillRef>
+          <a:effectRef idx="1">
+            <a:schemeClr val="accent1"/>
+          </a:effectRef>
+          <a:fontRef idx="minor">
+            <a:schemeClr val="tx1"/>
+          </a:fontRef>
+        </p:style>
+      </p:cxnSp>
+      <p:sp>
+        <p:nvSpPr>
+          <p:cNvPr id="32" name="Rectangle 31"/>
+          <p:cNvSpPr/>
+          <p:nvPr/>
+        </p:nvSpPr>
+        <p:spPr>
+          <a:xfrm>
+            <a:off x="4045356" y="4837175"/>
+            <a:ext cx="119735" cy="146304"/>
+          </a:xfrm>
+          <a:prstGeom prst="rect">
+            <a:avLst/>
+          </a:prstGeom>
+          <a:solidFill>
+            <a:srgbClr val="C76B3B"/>
+          </a:solidFill>
+          <a:ln w="10160">
+            <a:solidFill>
+              <a:srgbClr val="C76B3B"/>
+            </a:solidFill>
+          </a:ln>
+        </p:spPr>
+        <p:style>
+          <a:lnRef idx="1">
+            <a:schemeClr val="accent1"/>
+          </a:lnRef>
+          <a:fillRef idx="3">
+            <a:schemeClr val="accent1"/>
+          </a:fillRef>
+          <a:effectRef idx="2">
+            <a:schemeClr val="accent1"/>
+          </a:effectRef>
+          <a:fontRef idx="minor">
+            <a:schemeClr val="lt1"/>
+          </a:fontRef>
+        </p:style>
+        <p:txBody>
+          <a:bodyPr rtlCol="0" anchor="ctr"/>
+          <a:lstStyle/>
+          <a:p>
+            <a:pPr algn="ctr"/>
+          </a:p>
+        </p:txBody>
+      </p:sp>
+      <p:sp>
+        <p:nvSpPr>
           <p:cNvPr id="33" name="TextBox 32"/>
+          <p:cNvSpPr txBox="1"/>
+          <p:nvPr/>
+        </p:nvSpPr>
+        <p:spPr>
+          <a:xfrm>
+            <a:off x="6227064" y="4791455"/>
+            <a:ext cx="932688" cy="219456"/>
+          </a:xfrm>
+          <a:prstGeom prst="rect">
+            <a:avLst/>
+          </a:prstGeom>
+          <a:noFill/>
+        </p:spPr>
+        <p:txBody>
+          <a:bodyPr wrap="square" lIns="0" rIns="0" tIns="0" bIns="0" anchor="t">
+            <a:spAutoFit/>
+          </a:bodyPr>
+          <a:lstStyle/>
+          <a:p>
+            <a:pPr algn="r">
+              <a:spcAft>
+                <a:spcPts val="0"/>
+              </a:spcAft>
+            </a:pPr>
+            <a:r>
+              <a:rPr sz="900" b="1">
+                <a:solidFill>
+                  <a:srgbClr val="5D6D7E"/>
+                </a:solidFill>
+                <a:latin typeface="Aptos"/>
+              </a:rPr>
+              <a:t>-2,053</a:t>
+            </a:r>
+          </a:p>
+        </p:txBody>
+      </p:sp>
+      <p:sp>
+        <p:nvSpPr>
+          <p:cNvPr id="34" name="TextBox 33"/>
+          <p:cNvSpPr txBox="1"/>
+          <p:nvPr/>
+        </p:nvSpPr>
+        <p:spPr>
+          <a:xfrm>
+            <a:off x="896112" y="5266944"/>
+            <a:ext cx="1225296" cy="219456"/>
+          </a:xfrm>
+          <a:prstGeom prst="rect">
+            <a:avLst/>
+          </a:prstGeom>
+          <a:noFill/>
+        </p:spPr>
+        <p:txBody>
+          <a:bodyPr wrap="square" lIns="0" rIns="0" tIns="0" bIns="0" anchor="t">
+            <a:spAutoFit/>
+          </a:bodyPr>
+          <a:lstStyle/>
+          <a:p>
+            <a:pPr algn="l">
+              <a:spcAft>
+                <a:spcPts val="0"/>
+              </a:spcAft>
+            </a:pPr>
+            <a:r>
+              <a:rPr sz="919" b="1">
+                <a:solidFill>
+                  <a:srgbClr val="10263C"/>
+                </a:solidFill>
+                <a:latin typeface="Aptos"/>
+              </a:rPr>
+              <a:t>Net change</a:t>
+            </a:r>
+          </a:p>
+        </p:txBody>
+      </p:sp>
+      <p:sp>
+        <p:nvSpPr>
+          <p:cNvPr id="35" name="Rectangle 34"/>
+          <p:cNvSpPr/>
+          <p:nvPr/>
+        </p:nvSpPr>
+        <p:spPr>
+          <a:xfrm>
+            <a:off x="2286000" y="5303520"/>
+            <a:ext cx="3758184" cy="146304"/>
+          </a:xfrm>
+          <a:prstGeom prst="rect">
+            <a:avLst/>
+          </a:prstGeom>
+          <a:solidFill>
+            <a:srgbClr val="F0F4F7"/>
+          </a:solidFill>
+          <a:ln w="10160">
+            <a:solidFill>
+              <a:srgbClr val="F0F4F7"/>
+            </a:solidFill>
+          </a:ln>
+        </p:spPr>
+        <p:style>
+          <a:lnRef idx="1">
+            <a:schemeClr val="accent1"/>
+          </a:lnRef>
+          <a:fillRef idx="3">
+            <a:schemeClr val="accent1"/>
+          </a:fillRef>
+          <a:effectRef idx="2">
+            <a:schemeClr val="accent1"/>
+          </a:effectRef>
+          <a:fontRef idx="minor">
+            <a:schemeClr val="lt1"/>
+          </a:fontRef>
+        </p:style>
+        <p:txBody>
+          <a:bodyPr rtlCol="0" anchor="ctr"/>
+          <a:lstStyle/>
+          <a:p>
+            <a:pPr algn="ctr"/>
+          </a:p>
+        </p:txBody>
+      </p:sp>
+      <p:cxnSp>
+        <p:nvCxnSpPr>
+          <p:cNvPr id="36" name="Connector 35"/>
+          <p:cNvCxnSpPr/>
+          <p:nvPr/>
+        </p:nvCxnSpPr>
+        <p:spPr>
+          <a:xfrm>
+            <a:off x="4165092" y="5266944"/>
+            <a:ext cx="0" cy="219456"/>
+          </a:xfrm>
+          <a:prstGeom prst="line">
+            <a:avLst/>
+          </a:prstGeom>
+          <a:ln w="10160">
+            <a:solidFill>
+              <a:srgbClr val="9FB0C0"/>
+            </a:solidFill>
+          </a:ln>
+        </p:spPr>
+        <p:style>
+          <a:lnRef idx="2">
+            <a:schemeClr val="accent1"/>
+          </a:lnRef>
+          <a:fillRef idx="0">
+            <a:schemeClr val="accent1"/>
+          </a:fillRef>
+          <a:effectRef idx="1">
+            <a:schemeClr val="accent1"/>
+          </a:effectRef>
+          <a:fontRef idx="minor">
+            <a:schemeClr val="tx1"/>
+          </a:fontRef>
+        </p:style>
+      </p:cxnSp>
+      <p:sp>
+        <p:nvSpPr>
+          <p:cNvPr id="37" name="Rectangle 36"/>
+          <p:cNvSpPr/>
+          <p:nvPr/>
+        </p:nvSpPr>
+        <p:spPr>
+          <a:xfrm>
+            <a:off x="4165092" y="5303520"/>
+            <a:ext cx="1722780" cy="146304"/>
+          </a:xfrm>
+          <a:prstGeom prst="rect">
+            <a:avLst/>
+          </a:prstGeom>
+          <a:solidFill>
+            <a:srgbClr val="10263C"/>
+          </a:solidFill>
+          <a:ln w="10160">
+            <a:solidFill>
+              <a:srgbClr val="10263C"/>
+            </a:solidFill>
+          </a:ln>
+        </p:spPr>
+        <p:style>
+          <a:lnRef idx="1">
+            <a:schemeClr val="accent1"/>
+          </a:lnRef>
+          <a:fillRef idx="3">
+            <a:schemeClr val="accent1"/>
+          </a:fillRef>
+          <a:effectRef idx="2">
+            <a:schemeClr val="accent1"/>
+          </a:effectRef>
+          <a:fontRef idx="minor">
+            <a:schemeClr val="lt1"/>
+          </a:fontRef>
+        </p:style>
+        <p:txBody>
+          <a:bodyPr rtlCol="0" anchor="ctr"/>
+          <a:lstStyle/>
+          <a:p>
+            <a:pPr algn="ctr"/>
+          </a:p>
+        </p:txBody>
+      </p:sp>
+      <p:sp>
+        <p:nvSpPr>
+          <p:cNvPr id="38" name="TextBox 37"/>
+          <p:cNvSpPr txBox="1"/>
+          <p:nvPr/>
+        </p:nvSpPr>
+        <p:spPr>
+          <a:xfrm>
+            <a:off x="6227064" y="5257800"/>
+            <a:ext cx="932688" cy="219456"/>
+          </a:xfrm>
+          <a:prstGeom prst="rect">
+            <a:avLst/>
+          </a:prstGeom>
+          <a:noFill/>
+        </p:spPr>
+        <p:txBody>
+          <a:bodyPr wrap="square" lIns="0" rIns="0" tIns="0" bIns="0" anchor="t">
+            <a:spAutoFit/>
+          </a:bodyPr>
+          <a:lstStyle/>
+          <a:p>
+            <a:pPr algn="r">
+              <a:spcAft>
+                <a:spcPts val="0"/>
+              </a:spcAft>
+            </a:pPr>
+            <a:r>
+              <a:rPr sz="900" b="1">
+                <a:solidFill>
+                  <a:srgbClr val="10263C"/>
+                </a:solidFill>
+                <a:latin typeface="Aptos"/>
+              </a:rPr>
+              <a:t>+29,539</a:t>
+            </a:r>
+          </a:p>
+        </p:txBody>
+      </p:sp>
+      <p:sp>
+        <p:nvSpPr>
+          <p:cNvPr id="39" name="Rounded Rectangle 38"/>
+          <p:cNvSpPr/>
+          <p:nvPr/>
+        </p:nvSpPr>
+        <p:spPr>
+          <a:xfrm>
+            <a:off x="7754112" y="3383280"/>
+            <a:ext cx="3840480" cy="2514600"/>
+          </a:xfrm>
+          <a:prstGeom prst="roundRect">
+            <a:avLst/>
+          </a:prstGeom>
+          <a:solidFill>
+            <a:srgbClr val="10263C"/>
+          </a:solidFill>
+          <a:ln w="10160">
+            <a:solidFill>
+              <a:srgbClr val="10263C"/>
+            </a:solidFill>
+          </a:ln>
+        </p:spPr>
+        <p:style>
+          <a:lnRef idx="1">
+            <a:schemeClr val="accent1"/>
+          </a:lnRef>
+          <a:fillRef idx="3">
+            <a:schemeClr val="accent1"/>
+          </a:fillRef>
+          <a:effectRef idx="2">
+            <a:schemeClr val="accent1"/>
+          </a:effectRef>
+          <a:fontRef idx="minor">
+            <a:schemeClr val="lt1"/>
+          </a:fontRef>
+        </p:style>
+        <p:txBody>
+          <a:bodyPr rtlCol="0" anchor="ctr"/>
+          <a:lstStyle/>
+          <a:p>
+            <a:pPr algn="ctr"/>
+          </a:p>
+        </p:txBody>
+      </p:sp>
+      <p:sp>
+        <p:nvSpPr>
+          <p:cNvPr id="40" name="TextBox 39"/>
+          <p:cNvSpPr txBox="1"/>
+          <p:nvPr/>
+        </p:nvSpPr>
+        <p:spPr>
+          <a:xfrm>
+            <a:off x="8046720" y="3639312"/>
+            <a:ext cx="2560320" cy="201168"/>
+          </a:xfrm>
+          <a:prstGeom prst="rect">
+            <a:avLst/>
+          </a:prstGeom>
+          <a:noFill/>
+        </p:spPr>
+        <p:txBody>
+          <a:bodyPr wrap="square" lIns="0" rIns="0" tIns="0" bIns="0" anchor="t">
+            <a:spAutoFit/>
+          </a:bodyPr>
+          <a:lstStyle/>
+          <a:p>
+            <a:pPr algn="l">
+              <a:spcAft>
+                <a:spcPts val="0"/>
+              </a:spcAft>
+            </a:pPr>
+            <a:r>
+              <a:rPr sz="850" b="1">
+                <a:solidFill>
+                  <a:srgbClr val="8ED9D0"/>
+                </a:solidFill>
+                <a:latin typeface="Aptos"/>
+              </a:rPr>
+              <a:t>LATEST-YEAR READ</a:t>
+            </a:r>
+          </a:p>
+        </p:txBody>
+      </p:sp>
+      <p:sp>
+        <p:nvSpPr>
+          <p:cNvPr id="41" name="TextBox 40"/>
+          <p:cNvSpPr txBox="1"/>
+          <p:nvPr/>
+        </p:nvSpPr>
+        <p:spPr>
+          <a:xfrm>
+            <a:off x="8046720" y="4023360"/>
+            <a:ext cx="2194560" cy="365760"/>
+          </a:xfrm>
+          <a:prstGeom prst="rect">
+            <a:avLst/>
+          </a:prstGeom>
+          <a:noFill/>
+        </p:spPr>
+        <p:txBody>
+          <a:bodyPr wrap="square" lIns="0" rIns="0" tIns="0" bIns="0" anchor="t">
+            <a:spAutoFit/>
+          </a:bodyPr>
+          <a:lstStyle/>
+          <a:p>
+            <a:pPr algn="l">
+              <a:spcAft>
+                <a:spcPts val="0"/>
+              </a:spcAft>
+            </a:pPr>
+            <a:r>
+              <a:rPr sz="2200" b="1">
+                <a:solidFill>
+                  <a:srgbClr val="FFFFFF"/>
+                </a:solidFill>
+                <a:latin typeface="Aptos"/>
+              </a:rPr>
+              <a:t>+28,580</a:t>
+            </a:r>
+          </a:p>
+        </p:txBody>
+      </p:sp>
+      <p:sp>
+        <p:nvSpPr>
+          <p:cNvPr id="42" name="TextBox 41"/>
+          <p:cNvSpPr txBox="1"/>
+          <p:nvPr/>
+        </p:nvSpPr>
+        <p:spPr>
+          <a:xfrm>
+            <a:off x="8046720" y="4407408"/>
+            <a:ext cx="2926080" cy="320040"/>
+          </a:xfrm>
+          <a:prstGeom prst="rect">
+            <a:avLst/>
+          </a:prstGeom>
+          <a:noFill/>
+        </p:spPr>
+        <p:txBody>
+          <a:bodyPr wrap="square" lIns="0" rIns="0" tIns="0" bIns="0" anchor="t">
+            <a:spAutoFit/>
+          </a:bodyPr>
+          <a:lstStyle/>
+          <a:p>
+            <a:pPr algn="l">
+              <a:spcAft>
+                <a:spcPts val="0"/>
+              </a:spcAft>
+            </a:pPr>
+            <a:r>
+              <a:rPr sz="919" b="0">
+                <a:solidFill>
+                  <a:srgbClr val="D4DEE7"/>
+                </a:solidFill>
+                <a:latin typeface="Aptos"/>
+              </a:rPr>
+              <a:t>undergraduate change at public institutions</a:t>
+            </a:r>
+          </a:p>
+        </p:txBody>
+      </p:sp>
+      <p:cxnSp>
+        <p:nvCxnSpPr>
+          <p:cNvPr id="43" name="Connector 42"/>
+          <p:cNvCxnSpPr/>
+          <p:nvPr/>
+        </p:nvCxnSpPr>
+        <p:spPr>
+          <a:xfrm>
+            <a:off x="8046720" y="4846320"/>
+            <a:ext cx="2834640" cy="0"/>
+          </a:xfrm>
+          <a:prstGeom prst="line">
+            <a:avLst/>
+          </a:prstGeom>
+          <a:ln w="12700">
+            <a:solidFill>
+              <a:srgbClr val="3A4B5B"/>
+            </a:solidFill>
+          </a:ln>
+        </p:spPr>
+        <p:style>
+          <a:lnRef idx="2">
+            <a:schemeClr val="accent1"/>
+          </a:lnRef>
+          <a:fillRef idx="0">
+            <a:schemeClr val="accent1"/>
+          </a:fillRef>
+          <a:effectRef idx="1">
+            <a:schemeClr val="accent1"/>
+          </a:effectRef>
+          <a:fontRef idx="minor">
+            <a:schemeClr val="tx1"/>
+          </a:fontRef>
+        </p:style>
+      </p:cxnSp>
+      <p:sp>
+        <p:nvSpPr>
+          <p:cNvPr id="44" name="TextBox 43"/>
+          <p:cNvSpPr txBox="1"/>
+          <p:nvPr/>
+        </p:nvSpPr>
+        <p:spPr>
+          <a:xfrm>
+            <a:off x="8046720" y="5074920"/>
+            <a:ext cx="2194560" cy="347472"/>
+          </a:xfrm>
+          <a:prstGeom prst="rect">
+            <a:avLst/>
+          </a:prstGeom>
+          <a:noFill/>
+        </p:spPr>
+        <p:txBody>
+          <a:bodyPr wrap="square" lIns="0" rIns="0" tIns="0" bIns="0" anchor="t">
+            <a:spAutoFit/>
+          </a:bodyPr>
+          <a:lstStyle/>
+          <a:p>
+            <a:pPr algn="l">
+              <a:spcAft>
+                <a:spcPts val="0"/>
+              </a:spcAft>
+            </a:pPr>
+            <a:r>
+              <a:rPr sz="2000" b="1">
+                <a:solidFill>
+                  <a:srgbClr val="8ED9D0"/>
+                </a:solidFill>
+                <a:latin typeface="Aptos"/>
+              </a:rPr>
+              <a:t>+29,968</a:t>
+            </a:r>
+          </a:p>
+        </p:txBody>
+      </p:sp>
+      <p:sp>
+        <p:nvSpPr>
+          <p:cNvPr id="45" name="TextBox 44"/>
+          <p:cNvSpPr txBox="1"/>
+          <p:nvPr/>
+        </p:nvSpPr>
+        <p:spPr>
+          <a:xfrm>
+            <a:off x="8046720" y="5413248"/>
+            <a:ext cx="2926080" cy="274320"/>
+          </a:xfrm>
+          <a:prstGeom prst="rect">
+            <a:avLst/>
+          </a:prstGeom>
+          <a:noFill/>
+        </p:spPr>
+        <p:txBody>
+          <a:bodyPr wrap="square" lIns="0" rIns="0" tIns="0" bIns="0" anchor="t">
+            <a:spAutoFit/>
+          </a:bodyPr>
+          <a:lstStyle/>
+          <a:p>
+            <a:pPr algn="l">
+              <a:spcAft>
+                <a:spcPts val="0"/>
+              </a:spcAft>
+            </a:pPr>
+            <a:r>
+              <a:rPr sz="919" b="0">
+                <a:solidFill>
+                  <a:srgbClr val="D4DEE7"/>
+                </a:solidFill>
+                <a:latin typeface="Aptos"/>
+              </a:rPr>
+              <a:t>change at continuing institutions</a:t>
+            </a:r>
+          </a:p>
+        </p:txBody>
+      </p:sp>
+      <p:cxnSp>
+        <p:nvCxnSpPr>
+          <p:cNvPr id="46" name="Connector 45"/>
+          <p:cNvCxnSpPr/>
+          <p:nvPr/>
+        </p:nvCxnSpPr>
+        <p:spPr>
+          <a:xfrm>
+            <a:off x="594360" y="6510528"/>
+            <a:ext cx="10972800" cy="0"/>
+          </a:xfrm>
+          <a:prstGeom prst="line">
+            <a:avLst/>
+          </a:prstGeom>
+          <a:ln w="10160">
+            <a:solidFill>
+              <a:srgbClr val="D9E1E8"/>
+            </a:solidFill>
+          </a:ln>
+        </p:spPr>
+        <p:style>
+          <a:lnRef idx="2">
+            <a:schemeClr val="accent1"/>
+          </a:lnRef>
+          <a:fillRef idx="0">
+            <a:schemeClr val="accent1"/>
+          </a:fillRef>
+          <a:effectRef idx="1">
+            <a:schemeClr val="accent1"/>
+          </a:effectRef>
+          <a:fontRef idx="minor">
+            <a:schemeClr val="tx1"/>
+          </a:fontRef>
+        </p:style>
+      </p:cxnSp>
+      <p:sp>
+        <p:nvSpPr>
+          <p:cNvPr id="47" name="TextBox 46"/>
           <p:cNvSpPr txBox="1"/>
           <p:nvPr/>
         </p:nvSpPr>
@@ -4376,7 +4948,7 @@
       </p:sp>
       <p:sp>
         <p:nvSpPr>
-          <p:cNvPr id="34" name="TextBox 33"/>
+          <p:cNvPr id="48" name="TextBox 47"/>
           <p:cNvSpPr txBox="1"/>
           <p:nvPr/>
         </p:nvSpPr>
@@ -9996,7 +10568,7 @@
                 </a:solidFill>
                 <a:latin typeface="Aptos"/>
               </a:rPr>
-              <a:t>INTERPRETATION AND QA</a:t>
+              <a:t>PUBLICATION JUDGMENT</a:t>
             </a:r>
           </a:p>
         </p:txBody>
@@ -10009,8 +10581,8 @@
         </p:nvSpPr>
         <p:spPr>
           <a:xfrm>
-            <a:off x="621792" y="749808"/>
-            <a:ext cx="10744200" cy="566928"/>
+            <a:off x="621792" y="713232"/>
+            <a:ext cx="10744200" cy="749808"/>
           </a:xfrm>
           <a:prstGeom prst="rect">
             <a:avLst/>
@@ -10029,13 +10601,13 @@
               </a:spcAft>
             </a:pPr>
             <a:r>
-              <a:rPr sz="2800" b="1">
+              <a:rPr sz="2400" b="1">
                 <a:solidFill>
                   <a:srgbClr val="10263C"/>
                 </a:solidFill>
                 <a:latin typeface="Aptos"/>
               </a:rPr>
-              <a:t>Use the trend. Keep the boundaries visible.</a:t>
+              <a:t>The aggregate result is publishable. Ten institution claims remain held.</a:t>
             </a:r>
           </a:p>
         </p:txBody>
@@ -10048,7 +10620,7 @@
         </p:nvSpPr>
         <p:spPr>
           <a:xfrm>
-            <a:off x="621792" y="1298448"/>
+            <a:off x="621792" y="1481328"/>
             <a:ext cx="10652760" cy="274320"/>
           </a:xfrm>
           <a:prstGeom prst="rect">
@@ -10074,7 +10646,7 @@
                 </a:solidFill>
                 <a:latin typeface="Aptos"/>
               </a:rPr>
-              <a:t>Management summary over validated analytical outputs; definitions, vintage, and institution-level QA still govern reuse.</a:t>
+              <a:t>Automated flags trigger evidence review; unresolved institution interpretation stays out of public narrative.</a:t>
             </a:r>
           </a:p>
         </p:txBody>
@@ -10088,7 +10660,7 @@
         <p:spPr>
           <a:xfrm>
             <a:off x="621792" y="1847088"/>
-            <a:ext cx="5349240" cy="4315968"/>
+            <a:ext cx="3429000" cy="1216152"/>
           </a:xfrm>
           <a:prstGeom prst="roundRect">
             <a:avLst/>
@@ -10132,7 +10704,493 @@
         </p:nvSpPr>
         <p:spPr>
           <a:xfrm>
-            <a:off x="914400" y="2103120"/>
+            <a:off x="786384" y="1993392"/>
+            <a:ext cx="3099816" cy="219456"/>
+          </a:xfrm>
+          <a:prstGeom prst="rect">
+            <a:avLst/>
+          </a:prstGeom>
+          <a:noFill/>
+        </p:spPr>
+        <p:txBody>
+          <a:bodyPr wrap="square" lIns="0" rIns="0" tIns="0" bIns="0" anchor="t">
+            <a:spAutoFit/>
+          </a:bodyPr>
+          <a:lstStyle/>
+          <a:p>
+            <a:pPr algn="l">
+              <a:spcAft>
+                <a:spcPts val="0"/>
+              </a:spcAft>
+            </a:pPr>
+            <a:r>
+              <a:rPr sz="800" b="1">
+                <a:solidFill>
+                  <a:srgbClr val="5D6D7E"/>
+                </a:solidFill>
+                <a:latin typeface="Aptos"/>
+              </a:rPr>
+              <a:t>HIGH-PRIORITY REVIEWED</a:t>
+            </a:r>
+          </a:p>
+        </p:txBody>
+      </p:sp>
+      <p:sp>
+        <p:nvSpPr>
+          <p:cNvPr id="7" name="TextBox 6"/>
+          <p:cNvSpPr txBox="1"/>
+          <p:nvPr/>
+        </p:nvSpPr>
+        <p:spPr>
+          <a:xfrm>
+            <a:off x="786384" y="2295144"/>
+            <a:ext cx="3099816" cy="384048"/>
+          </a:xfrm>
+          <a:prstGeom prst="rect">
+            <a:avLst/>
+          </a:prstGeom>
+          <a:noFill/>
+        </p:spPr>
+        <p:txBody>
+          <a:bodyPr wrap="square" lIns="0" rIns="0" tIns="0" bIns="0" anchor="t">
+            <a:spAutoFit/>
+          </a:bodyPr>
+          <a:lstStyle/>
+          <a:p>
+            <a:pPr algn="l">
+              <a:spcAft>
+                <a:spcPts val="0"/>
+              </a:spcAft>
+            </a:pPr>
+            <a:r>
+              <a:rPr sz="2300" b="1">
+                <a:solidFill>
+                  <a:srgbClr val="10263C"/>
+                </a:solidFill>
+                <a:latin typeface="Aptos"/>
+              </a:rPr>
+              <a:t>27/27</a:t>
+            </a:r>
+          </a:p>
+        </p:txBody>
+      </p:sp>
+      <p:sp>
+        <p:nvSpPr>
+          <p:cNvPr id="8" name="TextBox 7"/>
+          <p:cNvSpPr txBox="1"/>
+          <p:nvPr/>
+        </p:nvSpPr>
+        <p:spPr>
+          <a:xfrm>
+            <a:off x="786384" y="2743200"/>
+            <a:ext cx="3099816" cy="182880"/>
+          </a:xfrm>
+          <a:prstGeom prst="rect">
+            <a:avLst/>
+          </a:prstGeom>
+          <a:noFill/>
+        </p:spPr>
+        <p:txBody>
+          <a:bodyPr wrap="square" lIns="0" rIns="0" tIns="0" bIns="0" anchor="t">
+            <a:spAutoFit/>
+          </a:bodyPr>
+          <a:lstStyle/>
+          <a:p>
+            <a:pPr algn="l">
+              <a:spcAft>
+                <a:spcPts val="0"/>
+              </a:spcAft>
+            </a:pPr>
+            <a:r>
+              <a:rPr sz="850" b="0">
+                <a:solidFill>
+                  <a:srgbClr val="5D6D7E"/>
+                </a:solidFill>
+                <a:latin typeface="Aptos"/>
+              </a:rPr>
+              <a:t>26 safe with context · 1 held</a:t>
+            </a:r>
+          </a:p>
+        </p:txBody>
+      </p:sp>
+      <p:sp>
+        <p:nvSpPr>
+          <p:cNvPr id="9" name="Rounded Rectangle 8"/>
+          <p:cNvSpPr/>
+          <p:nvPr/>
+        </p:nvSpPr>
+        <p:spPr>
+          <a:xfrm>
+            <a:off x="4224528" y="1847088"/>
+            <a:ext cx="3429000" cy="1216152"/>
+          </a:xfrm>
+          <a:prstGeom prst="roundRect">
+            <a:avLst/>
+          </a:prstGeom>
+          <a:solidFill>
+            <a:srgbClr val="FFFFFF"/>
+          </a:solidFill>
+          <a:ln w="10160">
+            <a:solidFill>
+              <a:srgbClr val="D9E1E8"/>
+            </a:solidFill>
+          </a:ln>
+        </p:spPr>
+        <p:style>
+          <a:lnRef idx="1">
+            <a:schemeClr val="accent1"/>
+          </a:lnRef>
+          <a:fillRef idx="3">
+            <a:schemeClr val="accent1"/>
+          </a:fillRef>
+          <a:effectRef idx="2">
+            <a:schemeClr val="accent1"/>
+          </a:effectRef>
+          <a:fontRef idx="minor">
+            <a:schemeClr val="lt1"/>
+          </a:fontRef>
+        </p:style>
+        <p:txBody>
+          <a:bodyPr rtlCol="0" anchor="ctr"/>
+          <a:lstStyle/>
+          <a:p>
+            <a:pPr algn="ctr"/>
+          </a:p>
+        </p:txBody>
+      </p:sp>
+      <p:sp>
+        <p:nvSpPr>
+          <p:cNvPr id="10" name="TextBox 9"/>
+          <p:cNvSpPr txBox="1"/>
+          <p:nvPr/>
+        </p:nvSpPr>
+        <p:spPr>
+          <a:xfrm>
+            <a:off x="4389120" y="1993392"/>
+            <a:ext cx="3099816" cy="219456"/>
+          </a:xfrm>
+          <a:prstGeom prst="rect">
+            <a:avLst/>
+          </a:prstGeom>
+          <a:noFill/>
+        </p:spPr>
+        <p:txBody>
+          <a:bodyPr wrap="square" lIns="0" rIns="0" tIns="0" bIns="0" anchor="t">
+            <a:spAutoFit/>
+          </a:bodyPr>
+          <a:lstStyle/>
+          <a:p>
+            <a:pPr algn="l">
+              <a:spcAft>
+                <a:spcPts val="0"/>
+              </a:spcAft>
+            </a:pPr>
+            <a:r>
+              <a:rPr sz="800" b="1">
+                <a:solidFill>
+                  <a:srgbClr val="5D6D7E"/>
+                </a:solidFill>
+                <a:latin typeface="Aptos"/>
+              </a:rPr>
+              <a:t>MEDIUM-PRIORITY REVIEWED</a:t>
+            </a:r>
+          </a:p>
+        </p:txBody>
+      </p:sp>
+      <p:sp>
+        <p:nvSpPr>
+          <p:cNvPr id="11" name="TextBox 10"/>
+          <p:cNvSpPr txBox="1"/>
+          <p:nvPr/>
+        </p:nvSpPr>
+        <p:spPr>
+          <a:xfrm>
+            <a:off x="4389120" y="2295144"/>
+            <a:ext cx="3099816" cy="384048"/>
+          </a:xfrm>
+          <a:prstGeom prst="rect">
+            <a:avLst/>
+          </a:prstGeom>
+          <a:noFill/>
+        </p:spPr>
+        <p:txBody>
+          <a:bodyPr wrap="square" lIns="0" rIns="0" tIns="0" bIns="0" anchor="t">
+            <a:spAutoFit/>
+          </a:bodyPr>
+          <a:lstStyle/>
+          <a:p>
+            <a:pPr algn="l">
+              <a:spcAft>
+                <a:spcPts val="0"/>
+              </a:spcAft>
+            </a:pPr>
+            <a:r>
+              <a:rPr sz="2300" b="1">
+                <a:solidFill>
+                  <a:srgbClr val="10263C"/>
+                </a:solidFill>
+                <a:latin typeface="Aptos"/>
+              </a:rPr>
+              <a:t>50/50</a:t>
+            </a:r>
+          </a:p>
+        </p:txBody>
+      </p:sp>
+      <p:sp>
+        <p:nvSpPr>
+          <p:cNvPr id="12" name="TextBox 11"/>
+          <p:cNvSpPr txBox="1"/>
+          <p:nvPr/>
+        </p:nvSpPr>
+        <p:spPr>
+          <a:xfrm>
+            <a:off x="4389120" y="2743200"/>
+            <a:ext cx="3099816" cy="182880"/>
+          </a:xfrm>
+          <a:prstGeom prst="rect">
+            <a:avLst/>
+          </a:prstGeom>
+          <a:noFill/>
+        </p:spPr>
+        <p:txBody>
+          <a:bodyPr wrap="square" lIns="0" rIns="0" tIns="0" bIns="0" anchor="t">
+            <a:spAutoFit/>
+          </a:bodyPr>
+          <a:lstStyle/>
+          <a:p>
+            <a:pPr algn="l">
+              <a:spcAft>
+                <a:spcPts val="0"/>
+              </a:spcAft>
+            </a:pPr>
+            <a:r>
+              <a:rPr sz="850" b="0">
+                <a:solidFill>
+                  <a:srgbClr val="5D6D7E"/>
+                </a:solidFill>
+                <a:latin typeface="Aptos"/>
+              </a:rPr>
+              <a:t>41 safe with context · 9 held</a:t>
+            </a:r>
+          </a:p>
+        </p:txBody>
+      </p:sp>
+      <p:sp>
+        <p:nvSpPr>
+          <p:cNvPr id="13" name="Rounded Rectangle 12"/>
+          <p:cNvSpPr/>
+          <p:nvPr/>
+        </p:nvSpPr>
+        <p:spPr>
+          <a:xfrm>
+            <a:off x="7827264" y="1847088"/>
+            <a:ext cx="3767328" cy="1216152"/>
+          </a:xfrm>
+          <a:prstGeom prst="roundRect">
+            <a:avLst/>
+          </a:prstGeom>
+          <a:solidFill>
+            <a:srgbClr val="10263C"/>
+          </a:solidFill>
+          <a:ln w="10160">
+            <a:solidFill>
+              <a:srgbClr val="10263C"/>
+            </a:solidFill>
+          </a:ln>
+        </p:spPr>
+        <p:style>
+          <a:lnRef idx="1">
+            <a:schemeClr val="accent1"/>
+          </a:lnRef>
+          <a:fillRef idx="3">
+            <a:schemeClr val="accent1"/>
+          </a:fillRef>
+          <a:effectRef idx="2">
+            <a:schemeClr val="accent1"/>
+          </a:effectRef>
+          <a:fontRef idx="minor">
+            <a:schemeClr val="lt1"/>
+          </a:fontRef>
+        </p:style>
+        <p:txBody>
+          <a:bodyPr rtlCol="0" anchor="ctr"/>
+          <a:lstStyle/>
+          <a:p>
+            <a:pPr algn="ctr"/>
+          </a:p>
+        </p:txBody>
+      </p:sp>
+      <p:sp>
+        <p:nvSpPr>
+          <p:cNvPr id="14" name="TextBox 13"/>
+          <p:cNvSpPr txBox="1"/>
+          <p:nvPr/>
+        </p:nvSpPr>
+        <p:spPr>
+          <a:xfrm>
+            <a:off x="7991856" y="1993392"/>
+            <a:ext cx="3438144" cy="219456"/>
+          </a:xfrm>
+          <a:prstGeom prst="rect">
+            <a:avLst/>
+          </a:prstGeom>
+          <a:noFill/>
+        </p:spPr>
+        <p:txBody>
+          <a:bodyPr wrap="square" lIns="0" rIns="0" tIns="0" bIns="0" anchor="t">
+            <a:spAutoFit/>
+          </a:bodyPr>
+          <a:lstStyle/>
+          <a:p>
+            <a:pPr algn="l">
+              <a:spcAft>
+                <a:spcPts val="0"/>
+              </a:spcAft>
+            </a:pPr>
+            <a:r>
+              <a:rPr sz="800" b="1">
+                <a:solidFill>
+                  <a:srgbClr val="9FB0C0"/>
+                </a:solidFill>
+                <a:latin typeface="Aptos"/>
+              </a:rPr>
+              <a:t>INSTITUTION-SPECIFIC CLAIMS HELD</a:t>
+            </a:r>
+          </a:p>
+        </p:txBody>
+      </p:sp>
+      <p:sp>
+        <p:nvSpPr>
+          <p:cNvPr id="15" name="TextBox 14"/>
+          <p:cNvSpPr txBox="1"/>
+          <p:nvPr/>
+        </p:nvSpPr>
+        <p:spPr>
+          <a:xfrm>
+            <a:off x="7991856" y="2295144"/>
+            <a:ext cx="3438144" cy="384048"/>
+          </a:xfrm>
+          <a:prstGeom prst="rect">
+            <a:avLst/>
+          </a:prstGeom>
+          <a:noFill/>
+        </p:spPr>
+        <p:txBody>
+          <a:bodyPr wrap="square" lIns="0" rIns="0" tIns="0" bIns="0" anchor="t">
+            <a:spAutoFit/>
+          </a:bodyPr>
+          <a:lstStyle/>
+          <a:p>
+            <a:pPr algn="l">
+              <a:spcAft>
+                <a:spcPts val="0"/>
+              </a:spcAft>
+            </a:pPr>
+            <a:r>
+              <a:rPr sz="2300" b="1">
+                <a:solidFill>
+                  <a:srgbClr val="FFFFFF"/>
+                </a:solidFill>
+                <a:latin typeface="Aptos"/>
+              </a:rPr>
+              <a:t>10</a:t>
+            </a:r>
+          </a:p>
+        </p:txBody>
+      </p:sp>
+      <p:sp>
+        <p:nvSpPr>
+          <p:cNvPr id="16" name="TextBox 15"/>
+          <p:cNvSpPr txBox="1"/>
+          <p:nvPr/>
+        </p:nvSpPr>
+        <p:spPr>
+          <a:xfrm>
+            <a:off x="7991856" y="2743200"/>
+            <a:ext cx="3438144" cy="182880"/>
+          </a:xfrm>
+          <a:prstGeom prst="rect">
+            <a:avLst/>
+          </a:prstGeom>
+          <a:noFill/>
+        </p:spPr>
+        <p:txBody>
+          <a:bodyPr wrap="square" lIns="0" rIns="0" tIns="0" bIns="0" anchor="t">
+            <a:spAutoFit/>
+          </a:bodyPr>
+          <a:lstStyle/>
+          <a:p>
+            <a:pPr algn="l">
+              <a:spcAft>
+                <a:spcPts val="0"/>
+              </a:spcAft>
+            </a:pPr>
+            <a:r>
+              <a:rPr sz="850" b="0">
+                <a:solidFill>
+                  <a:srgbClr val="D4DEE7"/>
+                </a:solidFill>
+                <a:latin typeface="Aptos"/>
+              </a:rPr>
+              <a:t>retained in aggregates · excluded from unsupported narrative</a:t>
+            </a:r>
+          </a:p>
+        </p:txBody>
+      </p:sp>
+      <p:sp>
+        <p:nvSpPr>
+          <p:cNvPr id="17" name="Rounded Rectangle 16"/>
+          <p:cNvSpPr/>
+          <p:nvPr/>
+        </p:nvSpPr>
+        <p:spPr>
+          <a:xfrm>
+            <a:off x="621792" y="3355848"/>
+            <a:ext cx="5349240" cy="2788920"/>
+          </a:xfrm>
+          <a:prstGeom prst="roundRect">
+            <a:avLst/>
+          </a:prstGeom>
+          <a:solidFill>
+            <a:srgbClr val="FFFFFF"/>
+          </a:solidFill>
+          <a:ln w="10160">
+            <a:solidFill>
+              <a:srgbClr val="D9E1E8"/>
+            </a:solidFill>
+          </a:ln>
+        </p:spPr>
+        <p:style>
+          <a:lnRef idx="1">
+            <a:schemeClr val="accent1"/>
+          </a:lnRef>
+          <a:fillRef idx="3">
+            <a:schemeClr val="accent1"/>
+          </a:fillRef>
+          <a:effectRef idx="2">
+            <a:schemeClr val="accent1"/>
+          </a:effectRef>
+          <a:fontRef idx="minor">
+            <a:schemeClr val="lt1"/>
+          </a:fontRef>
+        </p:style>
+        <p:txBody>
+          <a:bodyPr rtlCol="0" anchor="ctr"/>
+          <a:lstStyle/>
+          <a:p>
+            <a:pPr algn="ctr"/>
+          </a:p>
+        </p:txBody>
+      </p:sp>
+      <p:sp>
+        <p:nvSpPr>
+          <p:cNvPr id="18" name="TextBox 17"/>
+          <p:cNvSpPr txBox="1"/>
+          <p:nvPr/>
+        </p:nvSpPr>
+        <p:spPr>
+          <a:xfrm>
+            <a:off x="914400" y="3602736"/>
             <a:ext cx="4389120" cy="292608"/>
           </a:xfrm>
           <a:prstGeom prst="rect">
@@ -10158,20 +11216,20 @@
                 </a:solidFill>
                 <a:latin typeface="Aptos"/>
               </a:rPr>
-              <a:t>What a manager can take away</a:t>
-            </a:r>
-          </a:p>
-        </p:txBody>
-      </p:sp>
-      <p:sp>
-        <p:nvSpPr>
-          <p:cNvPr id="7" name="Oval 6"/>
+              <a:t>What can be used now</a:t>
+            </a:r>
+          </a:p>
+        </p:txBody>
+      </p:sp>
+      <p:sp>
+        <p:nvSpPr>
+          <p:cNvPr id="19" name="Oval 18"/>
           <p:cNvSpPr/>
           <p:nvPr/>
         </p:nvSpPr>
         <p:spPr>
           <a:xfrm>
-            <a:off x="914400" y="2724912"/>
+            <a:off x="914400" y="4169664"/>
             <a:ext cx="82296" cy="82296"/>
           </a:xfrm>
           <a:prstGeom prst="ellipse">
@@ -10210,13 +11268,13 @@
       </p:sp>
       <p:sp>
         <p:nvSpPr>
-          <p:cNvPr id="8" name="TextBox 7"/>
-          <p:cNvSpPr txBox="1"/>
-          <p:nvPr/>
-        </p:nvSpPr>
-        <p:spPr>
-          <a:xfrm>
-            <a:off x="1078992" y="2651760"/>
+          <p:cNvPr id="20" name="TextBox 19"/>
+          <p:cNvSpPr txBox="1"/>
+          <p:nvPr/>
+        </p:nvSpPr>
+        <p:spPr>
+          <a:xfrm>
+            <a:off x="1078992" y="4096512"/>
             <a:ext cx="4178808" cy="246888"/>
           </a:xfrm>
           <a:prstGeom prst="rect">
@@ -10242,20 +11300,20 @@
                 </a:solidFill>
                 <a:latin typeface="Aptos"/>
               </a:rPr>
-              <a:t>Latest direction</a:t>
-            </a:r>
-          </a:p>
-        </p:txBody>
-      </p:sp>
-      <p:sp>
-        <p:nvSpPr>
-          <p:cNvPr id="9" name="TextBox 8"/>
-          <p:cNvSpPr txBox="1"/>
-          <p:nvPr/>
-        </p:nvSpPr>
-        <p:spPr>
-          <a:xfrm>
-            <a:off x="1078992" y="2935224"/>
+              <a:t>Aggregate direction</a:t>
+            </a:r>
+          </a:p>
+        </p:txBody>
+      </p:sp>
+      <p:sp>
+        <p:nvSpPr>
+          <p:cNvPr id="21" name="TextBox 20"/>
+          <p:cNvSpPr txBox="1"/>
+          <p:nvPr/>
+        </p:nvSpPr>
+        <p:spPr>
+          <a:xfrm>
+            <a:off x="1078992" y="4379976"/>
             <a:ext cx="4178808" cy="457200"/>
           </a:xfrm>
           <a:prstGeom prst="rect">
@@ -10281,20 +11339,20 @@
                 </a:solidFill>
                 <a:latin typeface="Aptos"/>
               </a:rPr>
-              <a:t>2024 U.S. nonresident enrollment increased +29,539 (+2.9%) from 2023.</a:t>
-            </a:r>
-          </a:p>
-        </p:txBody>
-      </p:sp>
-      <p:sp>
-        <p:nvSpPr>
-          <p:cNvPr id="10" name="Oval 9"/>
+              <a:t>2024 enrollment increased +29,539 (+2.9%), led by undergraduate growth.</a:t>
+            </a:r>
+          </a:p>
+        </p:txBody>
+      </p:sp>
+      <p:sp>
+        <p:nvSpPr>
+          <p:cNvPr id="22" name="Oval 21"/>
           <p:cNvSpPr/>
           <p:nvPr/>
         </p:nvSpPr>
         <p:spPr>
           <a:xfrm>
-            <a:off x="914400" y="3529584"/>
+            <a:off x="914400" y="4828032"/>
             <a:ext cx="82296" cy="82296"/>
           </a:xfrm>
           <a:prstGeom prst="ellipse">
@@ -10333,13 +11391,13 @@
       </p:sp>
       <p:sp>
         <p:nvSpPr>
-          <p:cNvPr id="11" name="TextBox 10"/>
-          <p:cNvSpPr txBox="1"/>
-          <p:nvPr/>
-        </p:nvSpPr>
-        <p:spPr>
-          <a:xfrm>
-            <a:off x="1078992" y="3456432"/>
+          <p:cNvPr id="23" name="TextBox 22"/>
+          <p:cNvSpPr txBox="1"/>
+          <p:nvPr/>
+        </p:nvSpPr>
+        <p:spPr>
+          <a:xfrm>
+            <a:off x="1078992" y="4754880"/>
             <a:ext cx="4178808" cy="246888"/>
           </a:xfrm>
           <a:prstGeom prst="rect">
@@ -10365,20 +11423,20 @@
                 </a:solidFill>
                 <a:latin typeface="Aptos"/>
               </a:rPr>
-              <a:t>Recovery pattern</a:t>
-            </a:r>
-          </a:p>
-        </p:txBody>
-      </p:sp>
-      <p:sp>
-        <p:nvSpPr>
-          <p:cNvPr id="12" name="TextBox 11"/>
-          <p:cNvSpPr txBox="1"/>
-          <p:nvPr/>
-        </p:nvSpPr>
-        <p:spPr>
-          <a:xfrm>
-            <a:off x="1078992" y="3739896"/>
+              <a:t>Geographic context</a:t>
+            </a:r>
+          </a:p>
+        </p:txBody>
+      </p:sp>
+      <p:sp>
+        <p:nvSpPr>
+          <p:cNvPr id="24" name="TextBox 23"/>
+          <p:cNvSpPr txBox="1"/>
+          <p:nvPr/>
+        </p:nvSpPr>
+        <p:spPr>
+          <a:xfrm>
+            <a:off x="1078992" y="5038344"/>
             <a:ext cx="4178808" cy="457200"/>
           </a:xfrm>
           <a:prstGeom prst="rect">
@@ -10404,20 +11462,20 @@
                 </a:solidFill>
                 <a:latin typeface="Aptos"/>
               </a:rPr>
-              <a:t>33 states/DC are at or above 2019, but 18 remain below the pre-pandemic baseline.</a:t>
-            </a:r>
-          </a:p>
-        </p:txBody>
-      </p:sp>
-      <p:sp>
-        <p:nvSpPr>
-          <p:cNvPr id="13" name="Oval 12"/>
+              <a:t>33 states/DC are at or above 2019; 18 remain below.</a:t>
+            </a:r>
+          </a:p>
+        </p:txBody>
+      </p:sp>
+      <p:sp>
+        <p:nvSpPr>
+          <p:cNvPr id="25" name="Oval 24"/>
           <p:cNvSpPr/>
           <p:nvPr/>
         </p:nvSpPr>
         <p:spPr>
           <a:xfrm>
-            <a:off x="914400" y="4334256"/>
+            <a:off x="914400" y="5486400"/>
             <a:ext cx="82296" cy="82296"/>
           </a:xfrm>
           <a:prstGeom prst="ellipse">
@@ -10456,13 +11514,13 @@
       </p:sp>
       <p:sp>
         <p:nvSpPr>
-          <p:cNvPr id="14" name="TextBox 13"/>
-          <p:cNvSpPr txBox="1"/>
-          <p:nvPr/>
-        </p:nvSpPr>
-        <p:spPr>
-          <a:xfrm>
-            <a:off x="1078992" y="4261104"/>
+          <p:cNvPr id="26" name="TextBox 25"/>
+          <p:cNvSpPr txBox="1"/>
+          <p:nvPr/>
+        </p:nvSpPr>
+        <p:spPr>
+          <a:xfrm>
+            <a:off x="1078992" y="5413248"/>
             <a:ext cx="4178808" cy="246888"/>
           </a:xfrm>
           <a:prstGeom prst="rect">
@@ -10488,20 +11546,20 @@
                 </a:solidFill>
                 <a:latin typeface="Aptos"/>
               </a:rPr>
-              <a:t>Structural driver</a:t>
-            </a:r>
-          </a:p>
-        </p:txBody>
-      </p:sp>
-      <p:sp>
-        <p:nvSpPr>
-          <p:cNvPr id="15" name="TextBox 14"/>
-          <p:cNvSpPr txBox="1"/>
-          <p:nvPr/>
-        </p:nvSpPr>
-        <p:spPr>
-          <a:xfrm>
-            <a:off x="1078992" y="4544568"/>
+              <a:t>Next-release persistence gate</a:t>
+            </a:r>
+          </a:p>
+        </p:txBody>
+      </p:sp>
+      <p:sp>
+        <p:nvSpPr>
+          <p:cNvPr id="27" name="TextBox 26"/>
+          <p:cNvSpPr txBox="1"/>
+          <p:nvPr/>
+        </p:nvSpPr>
+        <p:spPr>
+          <a:xfrm>
+            <a:off x="1078992" y="5696712"/>
             <a:ext cx="4178808" cy="457200"/>
           </a:xfrm>
           <a:prstGeom prst="rect">
@@ -10527,144 +11585,21 @@
                 </a:solidFill>
                 <a:latin typeface="Aptos"/>
               </a:rPr>
-              <a:t>Over the full decade, growth was graduate-heavy and concentrated in private nonprofit institutions and continuing institutions.</a:t>
-            </a:r>
-          </a:p>
-        </p:txBody>
-      </p:sp>
-      <p:sp>
-        <p:nvSpPr>
-          <p:cNvPr id="16" name="Oval 15"/>
+              <a:t>Call the undergraduate shift broadly persistent only if the next complete release is positive nationally and in at least 26 of 51 states/DC.</a:t>
+            </a:r>
+          </a:p>
+        </p:txBody>
+      </p:sp>
+      <p:sp>
+        <p:nvSpPr>
+          <p:cNvPr id="28" name="Rounded Rectangle 27"/>
           <p:cNvSpPr/>
           <p:nvPr/>
         </p:nvSpPr>
         <p:spPr>
           <a:xfrm>
-            <a:off x="914400" y="5138928"/>
-            <a:ext cx="82296" cy="82296"/>
-          </a:xfrm>
-          <a:prstGeom prst="ellipse">
-            <a:avLst/>
-          </a:prstGeom>
-          <a:solidFill>
-            <a:srgbClr val="0B776E"/>
-          </a:solidFill>
-          <a:ln>
-            <a:solidFill>
-              <a:srgbClr val="0B776E"/>
-            </a:solidFill>
-          </a:ln>
-        </p:spPr>
-        <p:style>
-          <a:lnRef idx="1">
-            <a:schemeClr val="accent1"/>
-          </a:lnRef>
-          <a:fillRef idx="3">
-            <a:schemeClr val="accent1"/>
-          </a:fillRef>
-          <a:effectRef idx="2">
-            <a:schemeClr val="accent1"/>
-          </a:effectRef>
-          <a:fontRef idx="minor">
-            <a:schemeClr val="lt1"/>
-          </a:fontRef>
-        </p:style>
-        <p:txBody>
-          <a:bodyPr rtlCol="0" anchor="ctr"/>
-          <a:lstStyle/>
-          <a:p>
-            <a:pPr algn="ctr"/>
-          </a:p>
-        </p:txBody>
-      </p:sp>
-      <p:sp>
-        <p:nvSpPr>
-          <p:cNvPr id="17" name="TextBox 16"/>
-          <p:cNvSpPr txBox="1"/>
-          <p:nvPr/>
-        </p:nvSpPr>
-        <p:spPr>
-          <a:xfrm>
-            <a:off x="1078992" y="5065776"/>
-            <a:ext cx="4178808" cy="246888"/>
-          </a:xfrm>
-          <a:prstGeom prst="rect">
-            <a:avLst/>
-          </a:prstGeom>
-          <a:noFill/>
-        </p:spPr>
-        <p:txBody>
-          <a:bodyPr wrap="square" lIns="0" rIns="0" tIns="0" bIns="0" anchor="t">
-            <a:spAutoFit/>
-          </a:bodyPr>
-          <a:lstStyle/>
-          <a:p>
-            <a:pPr algn="l">
-              <a:spcAft>
-                <a:spcPts val="0"/>
-              </a:spcAft>
-            </a:pPr>
-            <a:r>
-              <a:rPr sz="1200" b="1">
-                <a:solidFill>
-                  <a:srgbClr val="10263C"/>
-                </a:solidFill>
-                <a:latin typeface="Aptos"/>
-              </a:rPr>
-              <a:t>Next reporting cycle</a:t>
-            </a:r>
-          </a:p>
-        </p:txBody>
-      </p:sp>
-      <p:sp>
-        <p:nvSpPr>
-          <p:cNvPr id="18" name="TextBox 17"/>
-          <p:cNvSpPr txBox="1"/>
-          <p:nvPr/>
-        </p:nvSpPr>
-        <p:spPr>
-          <a:xfrm>
-            <a:off x="1078992" y="5349240"/>
-            <a:ext cx="4178808" cy="457200"/>
-          </a:xfrm>
-          <a:prstGeom prst="rect">
-            <a:avLst/>
-          </a:prstGeom>
-          <a:noFill/>
-        </p:spPr>
-        <p:txBody>
-          <a:bodyPr wrap="square" lIns="0" rIns="0" tIns="0" bIns="0" anchor="t">
-            <a:spAutoFit/>
-          </a:bodyPr>
-          <a:lstStyle/>
-          <a:p>
-            <a:pPr algn="l">
-              <a:spcAft>
-                <a:spcPts val="0"/>
-              </a:spcAft>
-            </a:pPr>
-            <a:r>
-              <a:rPr sz="950" b="0">
-                <a:solidFill>
-                  <a:srgbClr val="5D6D7E"/>
-                </a:solidFill>
-                <a:latin typeface="Aptos"/>
-              </a:rPr>
-              <a:t>R01 is pre-specified: call the undergraduate shift broadly persistent only if the next complete release is positive nationally and in at least 26 of 51 states/DC.</a:t>
-            </a:r>
-          </a:p>
-        </p:txBody>
-      </p:sp>
-      <p:sp>
-        <p:nvSpPr>
-          <p:cNvPr id="19" name="Rounded Rectangle 18"/>
-          <p:cNvSpPr/>
-          <p:nvPr/>
-        </p:nvSpPr>
-        <p:spPr>
-          <a:xfrm>
-            <a:off x="6199632" y="1847088"/>
-            <a:ext cx="5394960" cy="4315968"/>
+            <a:off x="6199632" y="3355848"/>
+            <a:ext cx="5394960" cy="2788920"/>
           </a:xfrm>
           <a:prstGeom prst="roundRect">
             <a:avLst/>
@@ -10702,13 +11637,13 @@
       </p:sp>
       <p:sp>
         <p:nvSpPr>
-          <p:cNvPr id="20" name="TextBox 19"/>
-          <p:cNvSpPr txBox="1"/>
-          <p:nvPr/>
-        </p:nvSpPr>
-        <p:spPr>
-          <a:xfrm>
-            <a:off x="6492240" y="2103120"/>
+          <p:cNvPr id="29" name="TextBox 28"/>
+          <p:cNvSpPr txBox="1"/>
+          <p:nvPr/>
+        </p:nvSpPr>
+        <p:spPr>
+          <a:xfrm>
+            <a:off x="6492240" y="3602736"/>
             <a:ext cx="4480560" cy="292608"/>
           </a:xfrm>
           <a:prstGeom prst="rect">
@@ -10741,13 +11676,13 @@
       </p:sp>
       <p:sp>
         <p:nvSpPr>
-          <p:cNvPr id="21" name="TextBox 20"/>
-          <p:cNvSpPr txBox="1"/>
-          <p:nvPr/>
-        </p:nvSpPr>
-        <p:spPr>
-          <a:xfrm>
-            <a:off x="6492240" y="2697480"/>
+          <p:cNvPr id="30" name="TextBox 29"/>
+          <p:cNvSpPr txBox="1"/>
+          <p:nvPr/>
+        </p:nvSpPr>
+        <p:spPr>
+          <a:xfrm>
+            <a:off x="6492240" y="4114800"/>
             <a:ext cx="310896" cy="219456"/>
           </a:xfrm>
           <a:prstGeom prst="rect">
@@ -10780,13 +11715,13 @@
       </p:sp>
       <p:sp>
         <p:nvSpPr>
-          <p:cNvPr id="22" name="TextBox 21"/>
-          <p:cNvSpPr txBox="1"/>
-          <p:nvPr/>
-        </p:nvSpPr>
-        <p:spPr>
-          <a:xfrm>
-            <a:off x="6876288" y="2679192"/>
+          <p:cNvPr id="31" name="TextBox 30"/>
+          <p:cNvSpPr txBox="1"/>
+          <p:nvPr/>
+        </p:nvSpPr>
+        <p:spPr>
+          <a:xfrm>
+            <a:off x="6876288" y="4096512"/>
             <a:ext cx="3959352" cy="246888"/>
           </a:xfrm>
           <a:prstGeom prst="rect">
@@ -10819,13 +11754,13 @@
       </p:sp>
       <p:sp>
         <p:nvSpPr>
-          <p:cNvPr id="23" name="TextBox 22"/>
-          <p:cNvSpPr txBox="1"/>
-          <p:nvPr/>
-        </p:nvSpPr>
-        <p:spPr>
-          <a:xfrm>
-            <a:off x="6876288" y="2962656"/>
+          <p:cNvPr id="32" name="TextBox 31"/>
+          <p:cNvSpPr txBox="1"/>
+          <p:nvPr/>
+        </p:nvSpPr>
+        <p:spPr>
+          <a:xfrm>
+            <a:off x="6876288" y="4379976"/>
             <a:ext cx="3959352" cy="457200"/>
           </a:xfrm>
           <a:prstGeom prst="rect">
@@ -10858,13 +11793,13 @@
       </p:sp>
       <p:sp>
         <p:nvSpPr>
-          <p:cNvPr id="24" name="TextBox 23"/>
-          <p:cNvSpPr txBox="1"/>
-          <p:nvPr/>
-        </p:nvSpPr>
-        <p:spPr>
-          <a:xfrm>
-            <a:off x="6492240" y="3483864"/>
+          <p:cNvPr id="33" name="TextBox 32"/>
+          <p:cNvSpPr txBox="1"/>
+          <p:nvPr/>
+        </p:nvSpPr>
+        <p:spPr>
+          <a:xfrm>
+            <a:off x="6492240" y="4773168"/>
             <a:ext cx="310896" cy="219456"/>
           </a:xfrm>
           <a:prstGeom prst="rect">
@@ -10897,13 +11832,13 @@
       </p:sp>
       <p:sp>
         <p:nvSpPr>
-          <p:cNvPr id="25" name="TextBox 24"/>
-          <p:cNvSpPr txBox="1"/>
-          <p:nvPr/>
-        </p:nvSpPr>
-        <p:spPr>
-          <a:xfrm>
-            <a:off x="6876288" y="3465576"/>
+          <p:cNvPr id="34" name="TextBox 33"/>
+          <p:cNvSpPr txBox="1"/>
+          <p:nvPr/>
+        </p:nvSpPr>
+        <p:spPr>
+          <a:xfrm>
+            <a:off x="6876288" y="4754880"/>
             <a:ext cx="3959352" cy="246888"/>
           </a:xfrm>
           <a:prstGeom prst="rect">
@@ -10936,13 +11871,13 @@
       </p:sp>
       <p:sp>
         <p:nvSpPr>
-          <p:cNvPr id="26" name="TextBox 25"/>
-          <p:cNvSpPr txBox="1"/>
-          <p:nvPr/>
-        </p:nvSpPr>
-        <p:spPr>
-          <a:xfrm>
-            <a:off x="6876288" y="3749039"/>
+          <p:cNvPr id="35" name="TextBox 34"/>
+          <p:cNvSpPr txBox="1"/>
+          <p:nvPr/>
+        </p:nvSpPr>
+        <p:spPr>
+          <a:xfrm>
+            <a:off x="6876288" y="5038344"/>
             <a:ext cx="3959352" cy="457200"/>
           </a:xfrm>
           <a:prstGeom prst="rect">
@@ -10975,13 +11910,13 @@
       </p:sp>
       <p:sp>
         <p:nvSpPr>
-          <p:cNvPr id="27" name="TextBox 26"/>
-          <p:cNvSpPr txBox="1"/>
-          <p:nvPr/>
-        </p:nvSpPr>
-        <p:spPr>
-          <a:xfrm>
-            <a:off x="6492240" y="4270248"/>
+          <p:cNvPr id="36" name="TextBox 35"/>
+          <p:cNvSpPr txBox="1"/>
+          <p:nvPr/>
+        </p:nvSpPr>
+        <p:spPr>
+          <a:xfrm>
+            <a:off x="6492240" y="5431536"/>
             <a:ext cx="310896" cy="219456"/>
           </a:xfrm>
           <a:prstGeom prst="rect">
@@ -11014,13 +11949,13 @@
       </p:sp>
       <p:sp>
         <p:nvSpPr>
-          <p:cNvPr id="28" name="TextBox 27"/>
-          <p:cNvSpPr txBox="1"/>
-          <p:nvPr/>
-        </p:nvSpPr>
-        <p:spPr>
-          <a:xfrm>
-            <a:off x="6876288" y="4251960"/>
+          <p:cNvPr id="37" name="TextBox 36"/>
+          <p:cNvSpPr txBox="1"/>
+          <p:nvPr/>
+        </p:nvSpPr>
+        <p:spPr>
+          <a:xfrm>
+            <a:off x="6876288" y="5413248"/>
             <a:ext cx="3959352" cy="246888"/>
           </a:xfrm>
           <a:prstGeom prst="rect">
@@ -11046,20 +11981,20 @@
                 </a:solidFill>
                 <a:latin typeface="Aptos"/>
               </a:rPr>
-              <a:t>Institution flags</a:t>
-            </a:r>
-          </a:p>
-        </p:txBody>
-      </p:sp>
-      <p:sp>
-        <p:nvSpPr>
-          <p:cNvPr id="29" name="TextBox 28"/>
-          <p:cNvSpPr txBox="1"/>
-          <p:nvPr/>
-        </p:nvSpPr>
-        <p:spPr>
-          <a:xfrm>
-            <a:off x="6876288" y="4535424"/>
+              <a:t>Authority</a:t>
+            </a:r>
+          </a:p>
+        </p:txBody>
+      </p:sp>
+      <p:sp>
+        <p:nvSpPr>
+          <p:cNvPr id="38" name="TextBox 37"/>
+          <p:cNvSpPr txBox="1"/>
+          <p:nvPr/>
+        </p:nvSpPr>
+        <p:spPr>
+          <a:xfrm>
+            <a:off x="6876288" y="5696712"/>
             <a:ext cx="3959352" cy="457200"/>
           </a:xfrm>
           <a:prstGeom prst="rect">
@@ -11085,170 +12020,14 @@
                 </a:solidFill>
                 <a:latin typeface="Aptos"/>
               </a:rPr>
-              <a:t>Large institution-level movements are triaged and evidence-reviewed before they support institution-specific public claims.</a:t>
-            </a:r>
-          </a:p>
-        </p:txBody>
-      </p:sp>
-      <p:sp>
-        <p:nvSpPr>
-          <p:cNvPr id="30" name="TextBox 29"/>
-          <p:cNvSpPr txBox="1"/>
-          <p:nvPr/>
-        </p:nvSpPr>
-        <p:spPr>
-          <a:xfrm>
-            <a:off x="6492240" y="5056631"/>
-            <a:ext cx="310896" cy="219456"/>
-          </a:xfrm>
-          <a:prstGeom prst="rect">
-            <a:avLst/>
-          </a:prstGeom>
-          <a:noFill/>
-        </p:spPr>
-        <p:txBody>
-          <a:bodyPr wrap="square" lIns="0" rIns="0" tIns="0" bIns="0" anchor="t">
-            <a:spAutoFit/>
-          </a:bodyPr>
-          <a:lstStyle/>
-          <a:p>
-            <a:pPr algn="l">
-              <a:spcAft>
-                <a:spcPts val="0"/>
-              </a:spcAft>
-            </a:pPr>
-            <a:r>
-              <a:rPr sz="900" b="1">
-                <a:solidFill>
-                  <a:srgbClr val="07564F"/>
-                </a:solidFill>
-                <a:latin typeface="Aptos"/>
-              </a:rPr>
-              <a:t>04</a:t>
-            </a:r>
-          </a:p>
-        </p:txBody>
-      </p:sp>
-      <p:sp>
-        <p:nvSpPr>
-          <p:cNvPr id="31" name="TextBox 30"/>
-          <p:cNvSpPr txBox="1"/>
-          <p:nvPr/>
-        </p:nvSpPr>
-        <p:spPr>
-          <a:xfrm>
-            <a:off x="6876288" y="5038344"/>
-            <a:ext cx="3959352" cy="246888"/>
-          </a:xfrm>
-          <a:prstGeom prst="rect">
-            <a:avLst/>
-          </a:prstGeom>
-          <a:noFill/>
-        </p:spPr>
-        <p:txBody>
-          <a:bodyPr wrap="square" lIns="0" rIns="0" tIns="0" bIns="0" anchor="t">
-            <a:spAutoFit/>
-          </a:bodyPr>
-          <a:lstStyle/>
-          <a:p>
-            <a:pPr algn="l">
-              <a:spcAft>
-                <a:spcPts val="0"/>
-              </a:spcAft>
-            </a:pPr>
-            <a:r>
-              <a:rPr sz="1200" b="1">
-                <a:solidFill>
-                  <a:srgbClr val="10263C"/>
-                </a:solidFill>
-                <a:latin typeface="Aptos"/>
-              </a:rPr>
-              <a:t>Authority</a:t>
-            </a:r>
-          </a:p>
-        </p:txBody>
-      </p:sp>
-      <p:sp>
-        <p:nvSpPr>
-          <p:cNvPr id="32" name="TextBox 31"/>
-          <p:cNvSpPr txBox="1"/>
-          <p:nvPr/>
-        </p:nvSpPr>
-        <p:spPr>
-          <a:xfrm>
-            <a:off x="6876288" y="5321807"/>
-            <a:ext cx="3959352" cy="457200"/>
-          </a:xfrm>
-          <a:prstGeom prst="rect">
-            <a:avLst/>
-          </a:prstGeom>
-          <a:noFill/>
-        </p:spPr>
-        <p:txBody>
-          <a:bodyPr wrap="square" lIns="0" rIns="0" tIns="0" bIns="0" anchor="t">
-            <a:spAutoFit/>
-          </a:bodyPr>
-          <a:lstStyle/>
-          <a:p>
-            <a:pPr algn="l">
-              <a:spcAft>
-                <a:spcPts val="0"/>
-              </a:spcAft>
-            </a:pPr>
-            <a:r>
-              <a:rPr sz="950" b="0">
-                <a:solidFill>
-                  <a:srgbClr val="5D6D7E"/>
-                </a:solidFill>
-                <a:latin typeface="Aptos"/>
-              </a:rPr>
               <a:t>CSV/JSON outputs remain authoritative; this PPTX, the Excel workbook, PDF, and website are downstream presentation artifacts.</a:t>
-            </a:r>
-          </a:p>
-        </p:txBody>
-      </p:sp>
-      <p:sp>
-        <p:nvSpPr>
-          <p:cNvPr id="33" name="TextBox 32"/>
-          <p:cNvSpPr txBox="1"/>
-          <p:nvPr/>
-        </p:nvSpPr>
-        <p:spPr>
-          <a:xfrm>
-            <a:off x="6492240" y="5715000"/>
-            <a:ext cx="4434840" cy="347472"/>
-          </a:xfrm>
-          <a:prstGeom prst="rect">
-            <a:avLst/>
-          </a:prstGeom>
-          <a:noFill/>
-        </p:spPr>
-        <p:txBody>
-          <a:bodyPr wrap="square" lIns="0" rIns="0" tIns="0" bIns="0" anchor="t">
-            <a:spAutoFit/>
-          </a:bodyPr>
-          <a:lstStyle/>
-          <a:p>
-            <a:pPr algn="l">
-              <a:spcAft>
-                <a:spcPts val="0"/>
-              </a:spcAft>
-            </a:pPr>
-            <a:r>
-              <a:rPr sz="780" b="0">
-                <a:solidFill>
-                  <a:srgbClr val="5D6D7E"/>
-                </a:solidFill>
-                <a:latin typeface="Aptos"/>
-              </a:rPr>
-              <a:t>Source: NCES IPEDS Fall Enrollment and Institutional Characteristics, 2015–2024. Geography: 50 states + DC. Universe: degree-granting First Look/Digest Title IV institutions.</a:t>
             </a:r>
           </a:p>
         </p:txBody>
       </p:sp>
       <p:cxnSp>
         <p:nvCxnSpPr>
-          <p:cNvPr id="34" name="Connector 33"/>
+          <p:cNvPr id="39" name="Connector 38"/>
           <p:cNvCxnSpPr/>
           <p:nvPr/>
         </p:nvCxnSpPr>
@@ -11283,7 +12062,7 @@
       </p:cxnSp>
       <p:sp>
         <p:nvSpPr>
-          <p:cNvPr id="35" name="TextBox 34"/>
+          <p:cNvPr id="40" name="TextBox 39"/>
           <p:cNvSpPr txBox="1"/>
           <p:nvPr/>
         </p:nvSpPr>
@@ -11322,7 +12101,7 @@
       </p:sp>
       <p:sp>
         <p:nvSpPr>
-          <p:cNvPr id="36" name="TextBox 35"/>
+          <p:cNvPr id="41" name="TextBox 40"/>
           <p:cNvSpPr txBox="1"/>
           <p:nvPr/>
         </p:nvSpPr>

</xml_diff>

<commit_message>
Resolve Sacred Heart QA reporting discontinuity
</commit_message>
<xml_diff>
--- a/deliverables/management_briefing_deck.pptx
+++ b/deliverables/management_briefing_deck.pptx
@@ -10607,7 +10607,7 @@
                 </a:solidFill>
                 <a:latin typeface="Aptos"/>
               </a:rPr>
-              <a:t>The aggregate result is publishable. Ten institution claims remain held.</a:t>
+              <a:t>The aggregate result is publishable. 9 institution claims remain held.</a:t>
             </a:r>
           </a:p>
         </p:txBody>
@@ -10970,7 +10970,7 @@
                 </a:solidFill>
                 <a:latin typeface="Aptos"/>
               </a:rPr>
-              <a:t>41 safe with context · 9 held</a:t>
+              <a:t>42 safe with context · 8 held</a:t>
             </a:r>
           </a:p>
         </p:txBody>
@@ -11093,7 +11093,7 @@
                 </a:solidFill>
                 <a:latin typeface="Aptos"/>
               </a:rPr>
-              <a:t>10</a:t>
+              <a:t>9</a:t>
             </a:r>
           </a:p>
         </p:txBody>

</xml_diff>

<commit_message>
Resolve Lindsey Wilson QA direction and harden evidence links
</commit_message>
<xml_diff>
--- a/deliverables/management_briefing_deck.pptx
+++ b/deliverables/management_briefing_deck.pptx
@@ -10607,7 +10607,7 @@
                 </a:solidFill>
                 <a:latin typeface="Aptos"/>
               </a:rPr>
-              <a:t>The aggregate result is publishable. 9 institution claims remain held.</a:t>
+              <a:t>The aggregate result is publishable. 8 institution claims remain held.</a:t>
             </a:r>
           </a:p>
         </p:txBody>
@@ -10970,7 +10970,7 @@
                 </a:solidFill>
                 <a:latin typeface="Aptos"/>
               </a:rPr>
-              <a:t>42 safe with context · 8 held</a:t>
+              <a:t>43 safe with context · 7 held</a:t>
             </a:r>
           </a:p>
         </p:txBody>
@@ -11093,7 +11093,7 @@
                 </a:solidFill>
                 <a:latin typeface="Aptos"/>
               </a:rPr>
-              <a:t>9</a:t>
+              <a:t>8</a:t>
             </a:r>
           </a:p>
         </p:txBody>

</xml_diff>